<commit_message>
Deploying to gh-pages from @ tamanh-oxford/capacity-development@90f8d5ad8da85538004dbab65b46ab7d4f3c1073 🚀
</commit_message>
<xml_diff>
--- a/vi/data-frameworks/07-global-landscape-technologies.pptx
+++ b/vi/data-frameworks/07-global-landscape-technologies.pptx
@@ -3359,7 +3359,7 @@
             <a:pPr lvl="0"/>
             <a:r>
               <a:rPr/>
-              <a:t>Năm 2012, có khoảng</a:t>
+              <a:t>Năm 2012, có khoảng </a:t>
             </a:r>
             <a:r>
               <a:rPr b="1"/>
@@ -3367,18 +3367,18 @@
             </a:r>
             <a:r>
               <a:rPr/>
-              <a:t>ứng dụng/công cụ/nền tảng liên quan đến dữ liệu.</a:t>
+              <a:t> ứng dụng/công cụ/nền tảng liên quan đến dữ liệu.</a:t>
             </a:r>
           </a:p>
           <a:p>
             <a:pPr lvl="0"/>
             <a:r>
               <a:rPr/>
-              <a:t>Đến năm 2023, con số này đã tăng lên khoảng</a:t>
+              <a:t>Đến năm 2023, con số này đã tăng lên khoảng </a:t>
             </a:r>
             <a:r>
               <a:rPr b="1"/>
-              <a:t>1.416</a:t>
+              <a:t>1416</a:t>
             </a:r>
             <a:r>
               <a:rPr/>
@@ -3389,7 +3389,7 @@
             <a:pPr lvl="0"/>
             <a:r>
               <a:rPr/>
-              <a:t>Đến năm 2024, con số này đã tăng lên hơn</a:t>
+              <a:t>Đến năm 2024, con số này đã tăng lên hơn </a:t>
             </a:r>
             <a:r>
               <a:rPr b="1"/>

</xml_diff>